<commit_message>
VLC-1 1.1-draft: structural vs attested verification, evidence manifests, narrowed standards claim
</commit_message>
<xml_diff>
--- a/deck/VLC-1.pptx
+++ b/deck/VLC-1.pptx
@@ -9085,7 +9085,7 @@
                 <a:ea typeface="Cambria" pitchFamily="34" charset="-122"/>
                 <a:cs typeface="Cambria" pitchFamily="34" charset="-120"/>
               </a:rPr>
-              <a:t>Five levels, strictly ordered, each one necessary</a:t>
+              <a:t>Six levels, strictly ordered, each one necessary</a:t>
             </a:r>
             <a:endParaRPr lang="en-US" sz="3800" dirty="0"/>
           </a:p>
@@ -9124,7 +9124,7 @@
                 <a:ea typeface="Calibri" pitchFamily="34" charset="-122"/>
                 <a:cs typeface="Calibri" pitchFamily="34" charset="-120"/>
               </a:rPr>
-              <a:t>Each rung refuses an attack the rung below admits — proved, not asserted.</a:t>
+              <a:t>L0 to L5. Each rung refuses an attack the rung below admits — proved, not asserted.</a:t>
             </a:r>
             <a:endParaRPr lang="en-US" sz="1600" dirty="0"/>
           </a:p>
@@ -10178,7 +10178,7 @@
                 <a:ea typeface="Calibri" pitchFamily="34" charset="-122"/>
                 <a:cs typeface="Calibri" pitchFamily="34" charset="-120"/>
               </a:rPr>
-              <a:t>VLC-1 §4–§7A · 26 machine-checked results, 0 admitted, 0 axioms, all closed under the global context.</a:t>
+              <a:t>VLC-1 §4–§7A · 26 machine-checked results, 0 admitted, 0 axioms. Every report gives TWO numbers — what the checker recomputed, and what the producer asserted (§8.4).</a:t>
             </a:r>
             <a:endParaRPr lang="en-US" sz="1000" dirty="0"/>
           </a:p>

</xml_diff>